<commit_message>
Drop the empty placeholders that ghosted template prompt text onto repurposed slides
</commit_message>
<xml_diff>
--- a/docs/predictive-maintenance-tomastech.pptx
+++ b/docs/predictive-maintenance-tomastech.pptx
@@ -9454,60 +9454,6 @@
       </p:grpSpPr>
       <p:sp>
         <p:nvSpPr>
-          <p:cNvPr id="2" name="Title 1">
-            <a:extLst>
-              <a:ext uri="{FF2B5EF4-FFF2-40B4-BE49-F238E27FC236}">
-                <a16:creationId xmlns:a16="http://schemas.microsoft.com/office/drawing/2014/main" id="{F5F9ACFA-24F8-9FD6-421C-B4BDED8E37D4}"/>
-              </a:ext>
-            </a:extLst>
-          </p:cNvPr>
-          <p:cNvSpPr>
-            <a:spLocks noGrp="1"/>
-          </p:cNvSpPr>
-          <p:nvPr>
-            <p:ph type="title"/>
-          </p:nvPr>
-        </p:nvSpPr>
-        <p:spPr/>
-        <p:txBody>
-          <a:bodyPr wrap="square"/>
-          <a:lstStyle/>
-          <a:p>
-            <a:endParaRPr i="1" dirty="0">
-              <a:latin typeface="+mj-ea"/>
-              <a:ea typeface="+mj-ea"/>
-              <a:cs typeface="+mj-ea"/>
-            </a:endParaRPr>
-          </a:p>
-        </p:txBody>
-      </p:sp>
-      <p:sp>
-        <p:nvSpPr>
-          <p:cNvPr id="23" name="Text Placeholder 22">
-            <a:extLst>
-              <a:ext uri="{FF2B5EF4-FFF2-40B4-BE49-F238E27FC236}">
-                <a16:creationId xmlns:a16="http://schemas.microsoft.com/office/drawing/2014/main" id="{882F6CC0-BD94-F96E-9A1A-6A85738F1E85}"/>
-              </a:ext>
-            </a:extLst>
-          </p:cNvPr>
-          <p:cNvSpPr>
-            <a:spLocks noGrp="1"/>
-          </p:cNvSpPr>
-          <p:nvPr>
-            <p:ph type="body" sz="quarter" idx="10"/>
-          </p:nvPr>
-        </p:nvSpPr>
-        <p:spPr/>
-        <p:txBody>
-          <a:bodyPr/>
-          <a:lstStyle/>
-          <a:p>
-            <a:endParaRPr lang="en-US" dirty="0"/>
-          </a:p>
-        </p:txBody>
-      </p:sp>
-      <p:sp>
-        <p:nvSpPr>
           <p:cNvPr id="24" name="Rectangle 23"/>
           <p:cNvSpPr/>
           <p:nvPr/>
@@ -10436,29 +10382,6 @@
           <a:chExt cx="0" cy="0"/>
         </a:xfrm>
       </p:grpSpPr>
-      <p:sp>
-        <p:nvSpPr>
-          <p:cNvPr id="2" name="Title 1"/>
-          <p:cNvSpPr>
-            <a:spLocks noGrp="1"/>
-          </p:cNvSpPr>
-          <p:nvPr>
-            <p:ph type="title"/>
-          </p:nvPr>
-        </p:nvSpPr>
-        <p:spPr/>
-        <p:txBody>
-          <a:bodyPr/>
-          <a:lstStyle/>
-          <a:p>
-            <a:endParaRPr sz="4000" i="1" dirty="0">
-              <a:latin typeface="+mj-ea"/>
-              <a:ea typeface="+mj-ea"/>
-              <a:cs typeface="+mj-ea"/>
-            </a:endParaRPr>
-          </a:p>
-        </p:txBody>
-      </p:sp>
       <p:sp>
         <p:nvSpPr>
           <p:cNvPr id="3" name="Rectangle 2"/>

</xml_diff>